<commit_message>
docs: retro entry, team details in cup template, ignore local media
Co-Authored-By: Claude Opus 5.5 <noreply@anthropic.com>
</commit_message>
<xml_diff>
--- a/Submission Template _ AI Builder Cup.pptx
+++ b/Submission Template _ AI Builder Cup.pptx
@@ -7888,7 +7888,7 @@
       </p:sp>
       <p:sp>
         <p:nvSpPr>
-          <p:cNvPr id="1" name="Google Shape;151;p25"/>
+          <p:cNvPr id="2" name="Google Shape;151;p25"/>
           <p:cNvSpPr txBox="1"/>
           <p:nvPr/>
         </p:nvSpPr>
@@ -8340,7 +8340,16 @@
               </a:rPr>
               <a:t>GitHub Public Repository</a:t>
             </a:r>
-            <a:endParaRPr>
+            <a:r>
+              <a:rPr lang="en-PH" altLang="en-GB">
+                <a:latin typeface="Google Sans Flex Medium" panose="020B0503030502040204"/>
+                <a:ea typeface="Google Sans Flex Medium" panose="020B0503030502040204"/>
+                <a:cs typeface="Google Sans Flex Medium" panose="020B0503030502040204"/>
+                <a:sym typeface="Google Sans Flex Medium" panose="020B0503030502040204"/>
+              </a:rPr>
+              <a:t> : https://github.com/Gjandane/democratizing-google-data-studio</a:t>
+            </a:r>
+            <a:endParaRPr lang="en-PH" altLang="en-GB">
               <a:latin typeface="Google Sans Flex Medium" panose="020B0503030502040204"/>
               <a:ea typeface="Google Sans Flex Medium" panose="020B0503030502040204"/>
               <a:cs typeface="Google Sans Flex Medium" panose="020B0503030502040204"/>
@@ -8368,7 +8377,16 @@
               </a:rPr>
               <a:t>Demo Video Link (3 Minutes)</a:t>
             </a:r>
-            <a:endParaRPr>
+            <a:r>
+              <a:rPr lang="en-PH" altLang="en-GB">
+                <a:latin typeface="Google Sans Flex Medium" panose="020B0503030502040204"/>
+                <a:ea typeface="Google Sans Flex Medium" panose="020B0503030502040204"/>
+                <a:cs typeface="Google Sans Flex Medium" panose="020B0503030502040204"/>
+                <a:sym typeface="Google Sans Flex Medium" panose="020B0503030502040204"/>
+              </a:rPr>
+              <a:t>: https://drive.google.com/file/d/1eM3ZNkRyDO3jgebuO-JR65NQ-jKZhDsj/view?usp=sharing</a:t>
+            </a:r>
+            <a:endParaRPr lang="en-PH" altLang="en-GB">
               <a:latin typeface="Google Sans Flex Medium" panose="020B0503030502040204"/>
               <a:ea typeface="Google Sans Flex Medium" panose="020B0503030502040204"/>
               <a:cs typeface="Google Sans Flex Medium" panose="020B0503030502040204"/>
@@ -8396,7 +8414,16 @@
               </a:rPr>
               <a:t>Final Product Link</a:t>
             </a:r>
-            <a:endParaRPr>
+            <a:r>
+              <a:rPr lang="en-PH" altLang="en-GB">
+                <a:latin typeface="Google Sans Flex Medium" panose="020B0503030502040204"/>
+                <a:ea typeface="Google Sans Flex Medium" panose="020B0503030502040204"/>
+                <a:cs typeface="Google Sans Flex Medium" panose="020B0503030502040204"/>
+                <a:sym typeface="Google Sans Flex Medium" panose="020B0503030502040204"/>
+              </a:rPr>
+              <a:t>: https://dss-frontend-872000338860.asia-southeast1.run.app</a:t>
+            </a:r>
+            <a:endParaRPr lang="en-PH" altLang="en-GB">
               <a:latin typeface="Google Sans Flex Medium" panose="020B0503030502040204"/>
               <a:ea typeface="Google Sans Flex Medium" panose="020B0503030502040204"/>
               <a:cs typeface="Google Sans Flex Medium" panose="020B0503030502040204"/>

</xml_diff>